<commit_message>
added group wise count of all events
</commit_message>
<xml_diff>
--- a/assets/DLBTS-2025-template.pptx
+++ b/assets/DLBTS-2025-template.pptx
@@ -208,7 +208,7 @@
           <a:p>
             <a:fld id="{738101A2-AC81-4C84-9E51-3D77E367BB91}" type="datetimeFigureOut">
               <a:rPr lang="en-IN" smtClean="0"/>
-              <a:t>06-10-2026</a:t>
+              <a:t>13-10-2026</a:t>
             </a:fld>
             <a:endParaRPr lang="en-IN"/>
           </a:p>
@@ -709,7 +709,7 @@
           <a:p>
             <a:fld id="{53F3D846-1AF9-4F97-909D-D91FC385E87A}" type="datetimeFigureOut">
               <a:rPr lang="en-IN" smtClean="0"/>
-              <a:t>06-10-2026</a:t>
+              <a:t>13-10-2026</a:t>
             </a:fld>
             <a:endParaRPr lang="en-IN"/>
           </a:p>
@@ -909,7 +909,7 @@
           <a:p>
             <a:fld id="{53F3D846-1AF9-4F97-909D-D91FC385E87A}" type="datetimeFigureOut">
               <a:rPr lang="en-IN" smtClean="0"/>
-              <a:t>06-10-2026</a:t>
+              <a:t>13-10-2026</a:t>
             </a:fld>
             <a:endParaRPr lang="en-IN"/>
           </a:p>
@@ -1119,7 +1119,7 @@
           <a:p>
             <a:fld id="{53F3D846-1AF9-4F97-909D-D91FC385E87A}" type="datetimeFigureOut">
               <a:rPr lang="en-IN" smtClean="0"/>
-              <a:t>06-10-2026</a:t>
+              <a:t>13-10-2026</a:t>
             </a:fld>
             <a:endParaRPr lang="en-IN"/>
           </a:p>
@@ -1319,7 +1319,7 @@
           <a:p>
             <a:fld id="{53F3D846-1AF9-4F97-909D-D91FC385E87A}" type="datetimeFigureOut">
               <a:rPr lang="en-IN" smtClean="0"/>
-              <a:t>06-10-2026</a:t>
+              <a:t>13-10-2026</a:t>
             </a:fld>
             <a:endParaRPr lang="en-IN"/>
           </a:p>
@@ -1595,7 +1595,7 @@
           <a:p>
             <a:fld id="{53F3D846-1AF9-4F97-909D-D91FC385E87A}" type="datetimeFigureOut">
               <a:rPr lang="en-IN" smtClean="0"/>
-              <a:t>06-10-2026</a:t>
+              <a:t>13-10-2026</a:t>
             </a:fld>
             <a:endParaRPr lang="en-IN"/>
           </a:p>
@@ -1863,7 +1863,7 @@
           <a:p>
             <a:fld id="{53F3D846-1AF9-4F97-909D-D91FC385E87A}" type="datetimeFigureOut">
               <a:rPr lang="en-IN" smtClean="0"/>
-              <a:t>06-10-2026</a:t>
+              <a:t>13-10-2026</a:t>
             </a:fld>
             <a:endParaRPr lang="en-IN"/>
           </a:p>
@@ -2278,7 +2278,7 @@
           <a:p>
             <a:fld id="{53F3D846-1AF9-4F97-909D-D91FC385E87A}" type="datetimeFigureOut">
               <a:rPr lang="en-IN" smtClean="0"/>
-              <a:t>06-10-2026</a:t>
+              <a:t>13-10-2026</a:t>
             </a:fld>
             <a:endParaRPr lang="en-IN"/>
           </a:p>
@@ -2420,7 +2420,7 @@
           <a:p>
             <a:fld id="{53F3D846-1AF9-4F97-909D-D91FC385E87A}" type="datetimeFigureOut">
               <a:rPr lang="en-IN" smtClean="0"/>
-              <a:t>06-10-2026</a:t>
+              <a:t>13-10-2026</a:t>
             </a:fld>
             <a:endParaRPr lang="en-IN"/>
           </a:p>
@@ -2533,7 +2533,7 @@
           <a:p>
             <a:fld id="{53F3D846-1AF9-4F97-909D-D91FC385E87A}" type="datetimeFigureOut">
               <a:rPr lang="en-IN" smtClean="0"/>
-              <a:t>06-10-2026</a:t>
+              <a:t>13-10-2026</a:t>
             </a:fld>
             <a:endParaRPr lang="en-IN"/>
           </a:p>
@@ -2846,7 +2846,7 @@
           <a:p>
             <a:fld id="{53F3D846-1AF9-4F97-909D-D91FC385E87A}" type="datetimeFigureOut">
               <a:rPr lang="en-IN" smtClean="0"/>
-              <a:t>06-10-2026</a:t>
+              <a:t>13-10-2026</a:t>
             </a:fld>
             <a:endParaRPr lang="en-IN"/>
           </a:p>
@@ -3135,7 +3135,7 @@
           <a:p>
             <a:fld id="{53F3D846-1AF9-4F97-909D-D91FC385E87A}" type="datetimeFigureOut">
               <a:rPr lang="en-IN" smtClean="0"/>
-              <a:t>06-10-2026</a:t>
+              <a:t>13-10-2026</a:t>
             </a:fld>
             <a:endParaRPr lang="en-IN"/>
           </a:p>
@@ -3378,7 +3378,7 @@
           <a:p>
             <a:fld id="{53F3D846-1AF9-4F97-909D-D91FC385E87A}" type="datetimeFigureOut">
               <a:rPr lang="en-IN" smtClean="0"/>
-              <a:t>06-10-2026</a:t>
+              <a:t>13-10-2026</a:t>
             </a:fld>
             <a:endParaRPr lang="en-IN"/>
           </a:p>
@@ -3925,77 +3925,6 @@
           </a:p>
         </p:txBody>
       </p:sp>
-      <p:pic>
-        <p:nvPicPr>
-          <p:cNvPr id="6" name="Picture 4" descr="Sathya Sai Babas birthday ...">
-            <a:extLst>
-              <a:ext uri="{FF2B5EF4-FFF2-40B4-BE49-F238E27FC236}">
-                <a16:creationId xmlns:a16="http://schemas.microsoft.com/office/drawing/2014/main" id="{7620B092-1133-2BEB-EFFD-098F97B8EB74}"/>
-              </a:ext>
-            </a:extLst>
-          </p:cNvPr>
-          <p:cNvPicPr>
-            <a:picLocks noChangeAspect="1" noChangeArrowheads="1"/>
-          </p:cNvPicPr>
-          <p:nvPr/>
-        </p:nvPicPr>
-        <p:blipFill>
-          <a:blip r:embed="rId4">
-            <a:alphaModFix/>
-            <a:extLst>
-              <a:ext uri="{28A0092B-C50C-407E-A947-70E740481C1C}">
-                <a14:useLocalDpi xmlns:a14="http://schemas.microsoft.com/office/drawing/2010/main" val="0"/>
-              </a:ext>
-            </a:extLst>
-          </a:blip>
-          <a:srcRect/>
-          <a:stretch>
-            <a:fillRect/>
-          </a:stretch>
-        </p:blipFill>
-        <p:spPr bwMode="auto">
-          <a:xfrm>
-            <a:off x="200298" y="156754"/>
-            <a:ext cx="1202837" cy="1471749"/>
-          </a:xfrm>
-          <a:prstGeom prst="roundRect">
-            <a:avLst>
-              <a:gd name="adj" fmla="val 16667"/>
-            </a:avLst>
-          </a:prstGeom>
-          <a:ln>
-            <a:noFill/>
-          </a:ln>
-          <a:effectLst>
-            <a:outerShdw blurRad="76200" dist="38100" dir="7800000" algn="tl" rotWithShape="0">
-              <a:srgbClr val="000000">
-                <a:alpha val="40000"/>
-              </a:srgbClr>
-            </a:outerShdw>
-          </a:effectLst>
-          <a:scene3d>
-            <a:camera prst="orthographicFront"/>
-            <a:lightRig rig="contrasting" dir="t">
-              <a:rot lat="0" lon="0" rev="4200000"/>
-            </a:lightRig>
-          </a:scene3d>
-          <a:sp3d prstMaterial="plastic">
-            <a:bevelT w="381000" h="114300" prst="relaxedInset"/>
-            <a:contourClr>
-              <a:srgbClr val="969696"/>
-            </a:contourClr>
-          </a:sp3d>
-          <a:extLst>
-            <a:ext uri="{909E8E84-426E-40DD-AFC4-6F175D3DCCD1}">
-              <a14:hiddenFill xmlns:a14="http://schemas.microsoft.com/office/drawing/2010/main">
-                <a:solidFill>
-                  <a:srgbClr val="FFFFFF"/>
-                </a:solidFill>
-              </a14:hiddenFill>
-            </a:ext>
-          </a:extLst>
-        </p:spPr>
-      </p:pic>
       <p:sp>
         <p:nvSpPr>
           <p:cNvPr id="10" name="TextBox 9">
@@ -4170,7 +4099,7 @@
           <p:nvPr/>
         </p:nvPicPr>
         <p:blipFill>
-          <a:blip r:embed="rId5">
+          <a:blip r:embed="rId4">
             <a:extLst>
               <a:ext uri="{28A0092B-C50C-407E-A947-70E740481C1C}">
                 <a14:useLocalDpi xmlns:a14="http://schemas.microsoft.com/office/drawing/2010/main" val="0"/>
@@ -4206,7 +4135,7 @@
           <p:nvPr/>
         </p:nvPicPr>
         <p:blipFill>
-          <a:blip r:embed="rId6"/>
+          <a:blip r:embed="rId5"/>
           <a:stretch>
             <a:fillRect/>
           </a:stretch>
@@ -4243,6 +4172,55 @@
               <a:srgbClr val="969696"/>
             </a:contourClr>
           </a:sp3d>
+        </p:spPr>
+      </p:pic>
+      <p:pic>
+        <p:nvPicPr>
+          <p:cNvPr id="3" name="Picture 2">
+            <a:extLst>
+              <a:ext uri="{FF2B5EF4-FFF2-40B4-BE49-F238E27FC236}">
+                <a16:creationId xmlns:a16="http://schemas.microsoft.com/office/drawing/2014/main" id="{7F0FFB12-3EE2-D3A5-BB49-673C02DA117E}"/>
+              </a:ext>
+            </a:extLst>
+          </p:cNvPr>
+          <p:cNvPicPr>
+            <a:picLocks noChangeAspect="1"/>
+          </p:cNvPicPr>
+          <p:nvPr/>
+        </p:nvPicPr>
+        <p:blipFill>
+          <a:blip r:embed="rId6">
+            <a:extLst>
+              <a:ext uri="{28A0092B-C50C-407E-A947-70E740481C1C}">
+                <a14:useLocalDpi xmlns:a14="http://schemas.microsoft.com/office/drawing/2010/main" val="0"/>
+              </a:ext>
+            </a:extLst>
+          </a:blip>
+          <a:stretch>
+            <a:fillRect/>
+          </a:stretch>
+        </p:blipFill>
+        <p:spPr>
+          <a:xfrm>
+            <a:off x="118537" y="237068"/>
+            <a:ext cx="1388534" cy="1391436"/>
+          </a:xfrm>
+          <a:prstGeom prst="roundRect">
+            <a:avLst>
+              <a:gd name="adj" fmla="val 8594"/>
+            </a:avLst>
+          </a:prstGeom>
+          <a:solidFill>
+            <a:srgbClr val="FFFFFF">
+              <a:shade val="85000"/>
+            </a:srgbClr>
+          </a:solidFill>
+          <a:ln>
+            <a:noFill/>
+          </a:ln>
+          <a:effectLst>
+            <a:reflection blurRad="12700" stA="38000" endPos="28000" dist="5000" dir="5400000" sy="-100000" algn="bl" rotWithShape="0"/>
+          </a:effectLst>
         </p:spPr>
       </p:pic>
     </p:spTree>
@@ -4435,77 +4413,6 @@
           </a:p>
         </p:txBody>
       </p:sp>
-      <p:pic>
-        <p:nvPicPr>
-          <p:cNvPr id="6" name="Picture 4" descr="Sathya Sai Babas birthday ...">
-            <a:extLst>
-              <a:ext uri="{FF2B5EF4-FFF2-40B4-BE49-F238E27FC236}">
-                <a16:creationId xmlns:a16="http://schemas.microsoft.com/office/drawing/2014/main" id="{2DC483D3-B9AD-F6A5-D46F-A29EEB0A426B}"/>
-              </a:ext>
-            </a:extLst>
-          </p:cNvPr>
-          <p:cNvPicPr>
-            <a:picLocks noChangeAspect="1" noChangeArrowheads="1"/>
-          </p:cNvPicPr>
-          <p:nvPr/>
-        </p:nvPicPr>
-        <p:blipFill>
-          <a:blip r:embed="rId3">
-            <a:alphaModFix/>
-            <a:extLst>
-              <a:ext uri="{28A0092B-C50C-407E-A947-70E740481C1C}">
-                <a14:useLocalDpi xmlns:a14="http://schemas.microsoft.com/office/drawing/2010/main" val="0"/>
-              </a:ext>
-            </a:extLst>
-          </a:blip>
-          <a:srcRect/>
-          <a:stretch>
-            <a:fillRect/>
-          </a:stretch>
-        </p:blipFill>
-        <p:spPr bwMode="auto">
-          <a:xfrm>
-            <a:off x="200298" y="156754"/>
-            <a:ext cx="1202837" cy="1471749"/>
-          </a:xfrm>
-          <a:prstGeom prst="roundRect">
-            <a:avLst>
-              <a:gd name="adj" fmla="val 16667"/>
-            </a:avLst>
-          </a:prstGeom>
-          <a:ln>
-            <a:noFill/>
-          </a:ln>
-          <a:effectLst>
-            <a:outerShdw blurRad="76200" dist="38100" dir="7800000" algn="tl" rotWithShape="0">
-              <a:srgbClr val="000000">
-                <a:alpha val="40000"/>
-              </a:srgbClr>
-            </a:outerShdw>
-          </a:effectLst>
-          <a:scene3d>
-            <a:camera prst="orthographicFront"/>
-            <a:lightRig rig="contrasting" dir="t">
-              <a:rot lat="0" lon="0" rev="4200000"/>
-            </a:lightRig>
-          </a:scene3d>
-          <a:sp3d prstMaterial="plastic">
-            <a:bevelT w="381000" h="114300" prst="relaxedInset"/>
-            <a:contourClr>
-              <a:srgbClr val="969696"/>
-            </a:contourClr>
-          </a:sp3d>
-          <a:extLst>
-            <a:ext uri="{909E8E84-426E-40DD-AFC4-6F175D3DCCD1}">
-              <a14:hiddenFill xmlns:a14="http://schemas.microsoft.com/office/drawing/2010/main">
-                <a:solidFill>
-                  <a:srgbClr val="FFFFFF"/>
-                </a:solidFill>
-              </a14:hiddenFill>
-            </a:ext>
-          </a:extLst>
-        </p:spPr>
-      </p:pic>
       <p:sp>
         <p:nvSpPr>
           <p:cNvPr id="10" name="TextBox 9">
@@ -4976,7 +4883,7 @@
           <p:nvPr/>
         </p:nvPicPr>
         <p:blipFill>
-          <a:blip r:embed="rId4">
+          <a:blip r:embed="rId3">
             <a:extLst>
               <a:ext uri="{28A0092B-C50C-407E-A947-70E740481C1C}">
                 <a14:useLocalDpi xmlns:a14="http://schemas.microsoft.com/office/drawing/2010/main" val="0"/>
@@ -4995,6 +4902,55 @@
           <a:prstGeom prst="rect">
             <a:avLst/>
           </a:prstGeom>
+        </p:spPr>
+      </p:pic>
+      <p:pic>
+        <p:nvPicPr>
+          <p:cNvPr id="8" name="Picture 7">
+            <a:extLst>
+              <a:ext uri="{FF2B5EF4-FFF2-40B4-BE49-F238E27FC236}">
+                <a16:creationId xmlns:a16="http://schemas.microsoft.com/office/drawing/2014/main" id="{D3E3E6EC-6322-9A6A-9CD9-37686D2B88B1}"/>
+              </a:ext>
+            </a:extLst>
+          </p:cNvPr>
+          <p:cNvPicPr>
+            <a:picLocks noChangeAspect="1"/>
+          </p:cNvPicPr>
+          <p:nvPr/>
+        </p:nvPicPr>
+        <p:blipFill>
+          <a:blip r:embed="rId4">
+            <a:extLst>
+              <a:ext uri="{28A0092B-C50C-407E-A947-70E740481C1C}">
+                <a14:useLocalDpi xmlns:a14="http://schemas.microsoft.com/office/drawing/2010/main" val="0"/>
+              </a:ext>
+            </a:extLst>
+          </a:blip>
+          <a:stretch>
+            <a:fillRect/>
+          </a:stretch>
+        </p:blipFill>
+        <p:spPr>
+          <a:xfrm>
+            <a:off x="118537" y="237068"/>
+            <a:ext cx="1388534" cy="1391436"/>
+          </a:xfrm>
+          <a:prstGeom prst="roundRect">
+            <a:avLst>
+              <a:gd name="adj" fmla="val 8594"/>
+            </a:avLst>
+          </a:prstGeom>
+          <a:solidFill>
+            <a:srgbClr val="FFFFFF">
+              <a:shade val="85000"/>
+            </a:srgbClr>
+          </a:solidFill>
+          <a:ln>
+            <a:noFill/>
+          </a:ln>
+          <a:effectLst>
+            <a:reflection blurRad="12700" stA="38000" endPos="28000" dist="5000" dir="5400000" sy="-100000" algn="bl" rotWithShape="0"/>
+          </a:effectLst>
         </p:spPr>
       </p:pic>
     </p:spTree>
@@ -5187,77 +5143,6 @@
           </a:p>
         </p:txBody>
       </p:sp>
-      <p:pic>
-        <p:nvPicPr>
-          <p:cNvPr id="6" name="Picture 4" descr="Sathya Sai Babas birthday ...">
-            <a:extLst>
-              <a:ext uri="{FF2B5EF4-FFF2-40B4-BE49-F238E27FC236}">
-                <a16:creationId xmlns:a16="http://schemas.microsoft.com/office/drawing/2014/main" id="{65F0F537-FF47-8892-221A-15DE521CC1A5}"/>
-              </a:ext>
-            </a:extLst>
-          </p:cNvPr>
-          <p:cNvPicPr>
-            <a:picLocks noChangeAspect="1" noChangeArrowheads="1"/>
-          </p:cNvPicPr>
-          <p:nvPr/>
-        </p:nvPicPr>
-        <p:blipFill>
-          <a:blip r:embed="rId3">
-            <a:alphaModFix/>
-            <a:extLst>
-              <a:ext uri="{28A0092B-C50C-407E-A947-70E740481C1C}">
-                <a14:useLocalDpi xmlns:a14="http://schemas.microsoft.com/office/drawing/2010/main" val="0"/>
-              </a:ext>
-            </a:extLst>
-          </a:blip>
-          <a:srcRect/>
-          <a:stretch>
-            <a:fillRect/>
-          </a:stretch>
-        </p:blipFill>
-        <p:spPr bwMode="auto">
-          <a:xfrm>
-            <a:off x="200298" y="156754"/>
-            <a:ext cx="1202837" cy="1471749"/>
-          </a:xfrm>
-          <a:prstGeom prst="roundRect">
-            <a:avLst>
-              <a:gd name="adj" fmla="val 16667"/>
-            </a:avLst>
-          </a:prstGeom>
-          <a:ln>
-            <a:noFill/>
-          </a:ln>
-          <a:effectLst>
-            <a:outerShdw blurRad="76200" dist="38100" dir="7800000" algn="tl" rotWithShape="0">
-              <a:srgbClr val="000000">
-                <a:alpha val="40000"/>
-              </a:srgbClr>
-            </a:outerShdw>
-          </a:effectLst>
-          <a:scene3d>
-            <a:camera prst="orthographicFront"/>
-            <a:lightRig rig="contrasting" dir="t">
-              <a:rot lat="0" lon="0" rev="4200000"/>
-            </a:lightRig>
-          </a:scene3d>
-          <a:sp3d prstMaterial="plastic">
-            <a:bevelT w="381000" h="114300" prst="relaxedInset"/>
-            <a:contourClr>
-              <a:srgbClr val="969696"/>
-            </a:contourClr>
-          </a:sp3d>
-          <a:extLst>
-            <a:ext uri="{909E8E84-426E-40DD-AFC4-6F175D3DCCD1}">
-              <a14:hiddenFill xmlns:a14="http://schemas.microsoft.com/office/drawing/2010/main">
-                <a:solidFill>
-                  <a:srgbClr val="FFFFFF"/>
-                </a:solidFill>
-              </a14:hiddenFill>
-            </a:ext>
-          </a:extLst>
-        </p:spPr>
-      </p:pic>
       <p:sp>
         <p:nvSpPr>
           <p:cNvPr id="10" name="TextBox 9">
@@ -5728,7 +5613,7 @@
           <p:nvPr/>
         </p:nvPicPr>
         <p:blipFill>
-          <a:blip r:embed="rId4">
+          <a:blip r:embed="rId3">
             <a:extLst>
               <a:ext uri="{28A0092B-C50C-407E-A947-70E740481C1C}">
                 <a14:useLocalDpi xmlns:a14="http://schemas.microsoft.com/office/drawing/2010/main" val="0"/>
@@ -5747,6 +5632,55 @@
           <a:prstGeom prst="rect">
             <a:avLst/>
           </a:prstGeom>
+        </p:spPr>
+      </p:pic>
+      <p:pic>
+        <p:nvPicPr>
+          <p:cNvPr id="8" name="Picture 7">
+            <a:extLst>
+              <a:ext uri="{FF2B5EF4-FFF2-40B4-BE49-F238E27FC236}">
+                <a16:creationId xmlns:a16="http://schemas.microsoft.com/office/drawing/2014/main" id="{23EA2E21-21E3-7FE5-1919-2C613810BBE5}"/>
+              </a:ext>
+            </a:extLst>
+          </p:cNvPr>
+          <p:cNvPicPr>
+            <a:picLocks noChangeAspect="1"/>
+          </p:cNvPicPr>
+          <p:nvPr/>
+        </p:nvPicPr>
+        <p:blipFill>
+          <a:blip r:embed="rId4">
+            <a:extLst>
+              <a:ext uri="{28A0092B-C50C-407E-A947-70E740481C1C}">
+                <a14:useLocalDpi xmlns:a14="http://schemas.microsoft.com/office/drawing/2010/main" val="0"/>
+              </a:ext>
+            </a:extLst>
+          </a:blip>
+          <a:stretch>
+            <a:fillRect/>
+          </a:stretch>
+        </p:blipFill>
+        <p:spPr>
+          <a:xfrm>
+            <a:off x="118537" y="237068"/>
+            <a:ext cx="1388534" cy="1391436"/>
+          </a:xfrm>
+          <a:prstGeom prst="roundRect">
+            <a:avLst>
+              <a:gd name="adj" fmla="val 8594"/>
+            </a:avLst>
+          </a:prstGeom>
+          <a:solidFill>
+            <a:srgbClr val="FFFFFF">
+              <a:shade val="85000"/>
+            </a:srgbClr>
+          </a:solidFill>
+          <a:ln>
+            <a:noFill/>
+          </a:ln>
+          <a:effectLst>
+            <a:reflection blurRad="12700" stA="38000" endPos="28000" dist="5000" dir="5400000" sy="-100000" algn="bl" rotWithShape="0"/>
+          </a:effectLst>
         </p:spPr>
       </p:pic>
     </p:spTree>
@@ -5953,77 +5887,6 @@
           </a:p>
         </p:txBody>
       </p:sp>
-      <p:pic>
-        <p:nvPicPr>
-          <p:cNvPr id="6" name="Picture 4" descr="Sathya Sai Babas birthday ...">
-            <a:extLst>
-              <a:ext uri="{FF2B5EF4-FFF2-40B4-BE49-F238E27FC236}">
-                <a16:creationId xmlns:a16="http://schemas.microsoft.com/office/drawing/2014/main" id="{0E211AE6-BEB2-8D4D-469D-EC615B60C450}"/>
-              </a:ext>
-            </a:extLst>
-          </p:cNvPr>
-          <p:cNvPicPr>
-            <a:picLocks noChangeAspect="1" noChangeArrowheads="1"/>
-          </p:cNvPicPr>
-          <p:nvPr/>
-        </p:nvPicPr>
-        <p:blipFill>
-          <a:blip r:embed="rId3">
-            <a:alphaModFix/>
-            <a:extLst>
-              <a:ext uri="{28A0092B-C50C-407E-A947-70E740481C1C}">
-                <a14:useLocalDpi xmlns:a14="http://schemas.microsoft.com/office/drawing/2010/main" val="0"/>
-              </a:ext>
-            </a:extLst>
-          </a:blip>
-          <a:srcRect/>
-          <a:stretch>
-            <a:fillRect/>
-          </a:stretch>
-        </p:blipFill>
-        <p:spPr bwMode="auto">
-          <a:xfrm>
-            <a:off x="200298" y="156754"/>
-            <a:ext cx="1202837" cy="1471749"/>
-          </a:xfrm>
-          <a:prstGeom prst="roundRect">
-            <a:avLst>
-              <a:gd name="adj" fmla="val 16667"/>
-            </a:avLst>
-          </a:prstGeom>
-          <a:ln>
-            <a:noFill/>
-          </a:ln>
-          <a:effectLst>
-            <a:outerShdw blurRad="76200" dist="38100" dir="7800000" algn="tl" rotWithShape="0">
-              <a:srgbClr val="000000">
-                <a:alpha val="40000"/>
-              </a:srgbClr>
-            </a:outerShdw>
-          </a:effectLst>
-          <a:scene3d>
-            <a:camera prst="orthographicFront"/>
-            <a:lightRig rig="contrasting" dir="t">
-              <a:rot lat="0" lon="0" rev="4200000"/>
-            </a:lightRig>
-          </a:scene3d>
-          <a:sp3d prstMaterial="plastic">
-            <a:bevelT w="381000" h="114300" prst="relaxedInset"/>
-            <a:contourClr>
-              <a:srgbClr val="969696"/>
-            </a:contourClr>
-          </a:sp3d>
-          <a:extLst>
-            <a:ext uri="{909E8E84-426E-40DD-AFC4-6F175D3DCCD1}">
-              <a14:hiddenFill xmlns:a14="http://schemas.microsoft.com/office/drawing/2010/main">
-                <a:solidFill>
-                  <a:srgbClr val="FFFFFF"/>
-                </a:solidFill>
-              </a14:hiddenFill>
-            </a:ext>
-          </a:extLst>
-        </p:spPr>
-      </p:pic>
       <p:sp>
         <p:nvSpPr>
           <p:cNvPr id="10" name="TextBox 9">
@@ -6171,7 +6034,7 @@
           <p:nvPr/>
         </p:nvPicPr>
         <p:blipFill>
-          <a:blip r:embed="rId4">
+          <a:blip r:embed="rId3">
             <a:extLst>
               <a:ext uri="{28A0092B-C50C-407E-A947-70E740481C1C}">
                 <a14:useLocalDpi xmlns:a14="http://schemas.microsoft.com/office/drawing/2010/main" val="0"/>
@@ -6241,7 +6104,7 @@
           <p:nvPr/>
         </p:nvPicPr>
         <p:blipFill>
-          <a:blip r:embed="rId5">
+          <a:blip r:embed="rId4">
             <a:extLst>
               <a:ext uri="{28A0092B-C50C-407E-A947-70E740481C1C}">
                 <a14:useLocalDpi xmlns:a14="http://schemas.microsoft.com/office/drawing/2010/main" val="0"/>
@@ -6260,6 +6123,55 @@
           <a:prstGeom prst="rect">
             <a:avLst/>
           </a:prstGeom>
+        </p:spPr>
+      </p:pic>
+      <p:pic>
+        <p:nvPicPr>
+          <p:cNvPr id="7" name="Picture 6">
+            <a:extLst>
+              <a:ext uri="{FF2B5EF4-FFF2-40B4-BE49-F238E27FC236}">
+                <a16:creationId xmlns:a16="http://schemas.microsoft.com/office/drawing/2014/main" id="{AEB4B09C-CB15-B4CB-0343-EA8D258E79E8}"/>
+              </a:ext>
+            </a:extLst>
+          </p:cNvPr>
+          <p:cNvPicPr>
+            <a:picLocks noChangeAspect="1"/>
+          </p:cNvPicPr>
+          <p:nvPr/>
+        </p:nvPicPr>
+        <p:blipFill>
+          <a:blip r:embed="rId5">
+            <a:extLst>
+              <a:ext uri="{28A0092B-C50C-407E-A947-70E740481C1C}">
+                <a14:useLocalDpi xmlns:a14="http://schemas.microsoft.com/office/drawing/2010/main" val="0"/>
+              </a:ext>
+            </a:extLst>
+          </a:blip>
+          <a:stretch>
+            <a:fillRect/>
+          </a:stretch>
+        </p:blipFill>
+        <p:spPr>
+          <a:xfrm>
+            <a:off x="118537" y="237068"/>
+            <a:ext cx="1388534" cy="1391436"/>
+          </a:xfrm>
+          <a:prstGeom prst="roundRect">
+            <a:avLst>
+              <a:gd name="adj" fmla="val 8594"/>
+            </a:avLst>
+          </a:prstGeom>
+          <a:solidFill>
+            <a:srgbClr val="FFFFFF">
+              <a:shade val="85000"/>
+            </a:srgbClr>
+          </a:solidFill>
+          <a:ln>
+            <a:noFill/>
+          </a:ln>
+          <a:effectLst>
+            <a:reflection blurRad="12700" stA="38000" endPos="28000" dist="5000" dir="5400000" sy="-100000" algn="bl" rotWithShape="0"/>
+          </a:effectLst>
         </p:spPr>
       </p:pic>
     </p:spTree>
@@ -6452,77 +6364,6 @@
           </a:p>
         </p:txBody>
       </p:sp>
-      <p:pic>
-        <p:nvPicPr>
-          <p:cNvPr id="6" name="Picture 4" descr="Sathya Sai Babas birthday ...">
-            <a:extLst>
-              <a:ext uri="{FF2B5EF4-FFF2-40B4-BE49-F238E27FC236}">
-                <a16:creationId xmlns:a16="http://schemas.microsoft.com/office/drawing/2014/main" id="{5299A9F7-124C-70C8-06F8-D0E778F9DC1D}"/>
-              </a:ext>
-            </a:extLst>
-          </p:cNvPr>
-          <p:cNvPicPr>
-            <a:picLocks noChangeAspect="1" noChangeArrowheads="1"/>
-          </p:cNvPicPr>
-          <p:nvPr/>
-        </p:nvPicPr>
-        <p:blipFill>
-          <a:blip r:embed="rId3">
-            <a:alphaModFix/>
-            <a:extLst>
-              <a:ext uri="{28A0092B-C50C-407E-A947-70E740481C1C}">
-                <a14:useLocalDpi xmlns:a14="http://schemas.microsoft.com/office/drawing/2010/main" val="0"/>
-              </a:ext>
-            </a:extLst>
-          </a:blip>
-          <a:srcRect/>
-          <a:stretch>
-            <a:fillRect/>
-          </a:stretch>
-        </p:blipFill>
-        <p:spPr bwMode="auto">
-          <a:xfrm>
-            <a:off x="200298" y="156754"/>
-            <a:ext cx="1202837" cy="1471749"/>
-          </a:xfrm>
-          <a:prstGeom prst="roundRect">
-            <a:avLst>
-              <a:gd name="adj" fmla="val 16667"/>
-            </a:avLst>
-          </a:prstGeom>
-          <a:ln>
-            <a:noFill/>
-          </a:ln>
-          <a:effectLst>
-            <a:outerShdw blurRad="76200" dist="38100" dir="7800000" algn="tl" rotWithShape="0">
-              <a:srgbClr val="000000">
-                <a:alpha val="40000"/>
-              </a:srgbClr>
-            </a:outerShdw>
-          </a:effectLst>
-          <a:scene3d>
-            <a:camera prst="orthographicFront"/>
-            <a:lightRig rig="contrasting" dir="t">
-              <a:rot lat="0" lon="0" rev="4200000"/>
-            </a:lightRig>
-          </a:scene3d>
-          <a:sp3d prstMaterial="plastic">
-            <a:bevelT w="381000" h="114300" prst="relaxedInset"/>
-            <a:contourClr>
-              <a:srgbClr val="969696"/>
-            </a:contourClr>
-          </a:sp3d>
-          <a:extLst>
-            <a:ext uri="{909E8E84-426E-40DD-AFC4-6F175D3DCCD1}">
-              <a14:hiddenFill xmlns:a14="http://schemas.microsoft.com/office/drawing/2010/main">
-                <a:solidFill>
-                  <a:srgbClr val="FFFFFF"/>
-                </a:solidFill>
-              </a14:hiddenFill>
-            </a:ext>
-          </a:extLst>
-        </p:spPr>
-      </p:pic>
       <p:sp>
         <p:nvSpPr>
           <p:cNvPr id="10" name="TextBox 9">
@@ -6670,7 +6511,7 @@
           <p:nvPr/>
         </p:nvPicPr>
         <p:blipFill>
-          <a:blip r:embed="rId4">
+          <a:blip r:embed="rId3">
             <a:extLst>
               <a:ext uri="{28A0092B-C50C-407E-A947-70E740481C1C}">
                 <a14:useLocalDpi xmlns:a14="http://schemas.microsoft.com/office/drawing/2010/main" val="0"/>
@@ -6689,6 +6530,55 @@
           <a:prstGeom prst="rect">
             <a:avLst/>
           </a:prstGeom>
+        </p:spPr>
+      </p:pic>
+      <p:pic>
+        <p:nvPicPr>
+          <p:cNvPr id="9" name="Picture 8">
+            <a:extLst>
+              <a:ext uri="{FF2B5EF4-FFF2-40B4-BE49-F238E27FC236}">
+                <a16:creationId xmlns:a16="http://schemas.microsoft.com/office/drawing/2014/main" id="{311DF9B3-B75D-8380-EE3A-B4C7DE12C001}"/>
+              </a:ext>
+            </a:extLst>
+          </p:cNvPr>
+          <p:cNvPicPr>
+            <a:picLocks noChangeAspect="1"/>
+          </p:cNvPicPr>
+          <p:nvPr/>
+        </p:nvPicPr>
+        <p:blipFill>
+          <a:blip r:embed="rId4">
+            <a:extLst>
+              <a:ext uri="{28A0092B-C50C-407E-A947-70E740481C1C}">
+                <a14:useLocalDpi xmlns:a14="http://schemas.microsoft.com/office/drawing/2010/main" val="0"/>
+              </a:ext>
+            </a:extLst>
+          </a:blip>
+          <a:stretch>
+            <a:fillRect/>
+          </a:stretch>
+        </p:blipFill>
+        <p:spPr>
+          <a:xfrm>
+            <a:off x="118537" y="237068"/>
+            <a:ext cx="1388534" cy="1391436"/>
+          </a:xfrm>
+          <a:prstGeom prst="roundRect">
+            <a:avLst>
+              <a:gd name="adj" fmla="val 8594"/>
+            </a:avLst>
+          </a:prstGeom>
+          <a:solidFill>
+            <a:srgbClr val="FFFFFF">
+              <a:shade val="85000"/>
+            </a:srgbClr>
+          </a:solidFill>
+          <a:ln>
+            <a:noFill/>
+          </a:ln>
+          <a:effectLst>
+            <a:reflection blurRad="12700" stA="38000" endPos="28000" dist="5000" dir="5400000" sy="-100000" algn="bl" rotWithShape="0"/>
+          </a:effectLst>
         </p:spPr>
       </p:pic>
     </p:spTree>
@@ -6875,77 +6765,6 @@
           </a:p>
         </p:txBody>
       </p:sp>
-      <p:pic>
-        <p:nvPicPr>
-          <p:cNvPr id="6" name="Picture 4" descr="Sathya Sai Babas birthday ...">
-            <a:extLst>
-              <a:ext uri="{FF2B5EF4-FFF2-40B4-BE49-F238E27FC236}">
-                <a16:creationId xmlns:a16="http://schemas.microsoft.com/office/drawing/2014/main" id="{7A35B17B-1CB9-6DD5-4D71-F9849347AA21}"/>
-              </a:ext>
-            </a:extLst>
-          </p:cNvPr>
-          <p:cNvPicPr>
-            <a:picLocks noChangeAspect="1" noChangeArrowheads="1"/>
-          </p:cNvPicPr>
-          <p:nvPr/>
-        </p:nvPicPr>
-        <p:blipFill>
-          <a:blip r:embed="rId3">
-            <a:alphaModFix/>
-            <a:extLst>
-              <a:ext uri="{28A0092B-C50C-407E-A947-70E740481C1C}">
-                <a14:useLocalDpi xmlns:a14="http://schemas.microsoft.com/office/drawing/2010/main" val="0"/>
-              </a:ext>
-            </a:extLst>
-          </a:blip>
-          <a:srcRect/>
-          <a:stretch>
-            <a:fillRect/>
-          </a:stretch>
-        </p:blipFill>
-        <p:spPr bwMode="auto">
-          <a:xfrm>
-            <a:off x="200298" y="156754"/>
-            <a:ext cx="1202837" cy="1471749"/>
-          </a:xfrm>
-          <a:prstGeom prst="roundRect">
-            <a:avLst>
-              <a:gd name="adj" fmla="val 16667"/>
-            </a:avLst>
-          </a:prstGeom>
-          <a:ln>
-            <a:noFill/>
-          </a:ln>
-          <a:effectLst>
-            <a:outerShdw blurRad="76200" dist="38100" dir="7800000" algn="tl" rotWithShape="0">
-              <a:srgbClr val="000000">
-                <a:alpha val="40000"/>
-              </a:srgbClr>
-            </a:outerShdw>
-          </a:effectLst>
-          <a:scene3d>
-            <a:camera prst="orthographicFront"/>
-            <a:lightRig rig="contrasting" dir="t">
-              <a:rot lat="0" lon="0" rev="4200000"/>
-            </a:lightRig>
-          </a:scene3d>
-          <a:sp3d prstMaterial="plastic">
-            <a:bevelT w="381000" h="114300" prst="relaxedInset"/>
-            <a:contourClr>
-              <a:srgbClr val="969696"/>
-            </a:contourClr>
-          </a:sp3d>
-          <a:extLst>
-            <a:ext uri="{909E8E84-426E-40DD-AFC4-6F175D3DCCD1}">
-              <a14:hiddenFill xmlns:a14="http://schemas.microsoft.com/office/drawing/2010/main">
-                <a:solidFill>
-                  <a:srgbClr val="FFFFFF"/>
-                </a:solidFill>
-              </a14:hiddenFill>
-            </a:ext>
-          </a:extLst>
-        </p:spPr>
-      </p:pic>
       <p:sp>
         <p:nvSpPr>
           <p:cNvPr id="10" name="TextBox 9">
@@ -7422,7 +7241,7 @@
           <p:nvPr/>
         </p:nvPicPr>
         <p:blipFill>
-          <a:blip r:embed="rId4">
+          <a:blip r:embed="rId3">
             <a:extLst>
               <a:ext uri="{28A0092B-C50C-407E-A947-70E740481C1C}">
                 <a14:useLocalDpi xmlns:a14="http://schemas.microsoft.com/office/drawing/2010/main" val="0"/>
@@ -7441,6 +7260,55 @@
           <a:prstGeom prst="rect">
             <a:avLst/>
           </a:prstGeom>
+        </p:spPr>
+      </p:pic>
+      <p:pic>
+        <p:nvPicPr>
+          <p:cNvPr id="8" name="Picture 7">
+            <a:extLst>
+              <a:ext uri="{FF2B5EF4-FFF2-40B4-BE49-F238E27FC236}">
+                <a16:creationId xmlns:a16="http://schemas.microsoft.com/office/drawing/2014/main" id="{64DA82DF-8261-55F8-354E-98C055143982}"/>
+              </a:ext>
+            </a:extLst>
+          </p:cNvPr>
+          <p:cNvPicPr>
+            <a:picLocks noChangeAspect="1"/>
+          </p:cNvPicPr>
+          <p:nvPr/>
+        </p:nvPicPr>
+        <p:blipFill>
+          <a:blip r:embed="rId4">
+            <a:extLst>
+              <a:ext uri="{28A0092B-C50C-407E-A947-70E740481C1C}">
+                <a14:useLocalDpi xmlns:a14="http://schemas.microsoft.com/office/drawing/2010/main" val="0"/>
+              </a:ext>
+            </a:extLst>
+          </a:blip>
+          <a:stretch>
+            <a:fillRect/>
+          </a:stretch>
+        </p:blipFill>
+        <p:spPr>
+          <a:xfrm>
+            <a:off x="118537" y="237068"/>
+            <a:ext cx="1388534" cy="1391436"/>
+          </a:xfrm>
+          <a:prstGeom prst="roundRect">
+            <a:avLst>
+              <a:gd name="adj" fmla="val 8594"/>
+            </a:avLst>
+          </a:prstGeom>
+          <a:solidFill>
+            <a:srgbClr val="FFFFFF">
+              <a:shade val="85000"/>
+            </a:srgbClr>
+          </a:solidFill>
+          <a:ln>
+            <a:noFill/>
+          </a:ln>
+          <a:effectLst>
+            <a:reflection blurRad="12700" stA="38000" endPos="28000" dist="5000" dir="5400000" sy="-100000" algn="bl" rotWithShape="0"/>
+          </a:effectLst>
         </p:spPr>
       </p:pic>
     </p:spTree>
@@ -7633,77 +7501,6 @@
           </a:p>
         </p:txBody>
       </p:sp>
-      <p:pic>
-        <p:nvPicPr>
-          <p:cNvPr id="6" name="Picture 4" descr="Sathya Sai Babas birthday ...">
-            <a:extLst>
-              <a:ext uri="{FF2B5EF4-FFF2-40B4-BE49-F238E27FC236}">
-                <a16:creationId xmlns:a16="http://schemas.microsoft.com/office/drawing/2014/main" id="{A8805961-D5E5-1886-D5ED-31229ABDD0E3}"/>
-              </a:ext>
-            </a:extLst>
-          </p:cNvPr>
-          <p:cNvPicPr>
-            <a:picLocks noChangeAspect="1" noChangeArrowheads="1"/>
-          </p:cNvPicPr>
-          <p:nvPr/>
-        </p:nvPicPr>
-        <p:blipFill>
-          <a:blip r:embed="rId3">
-            <a:alphaModFix/>
-            <a:extLst>
-              <a:ext uri="{28A0092B-C50C-407E-A947-70E740481C1C}">
-                <a14:useLocalDpi xmlns:a14="http://schemas.microsoft.com/office/drawing/2010/main" val="0"/>
-              </a:ext>
-            </a:extLst>
-          </a:blip>
-          <a:srcRect/>
-          <a:stretch>
-            <a:fillRect/>
-          </a:stretch>
-        </p:blipFill>
-        <p:spPr bwMode="auto">
-          <a:xfrm>
-            <a:off x="200298" y="156754"/>
-            <a:ext cx="1202837" cy="1471749"/>
-          </a:xfrm>
-          <a:prstGeom prst="roundRect">
-            <a:avLst>
-              <a:gd name="adj" fmla="val 16667"/>
-            </a:avLst>
-          </a:prstGeom>
-          <a:ln>
-            <a:noFill/>
-          </a:ln>
-          <a:effectLst>
-            <a:outerShdw blurRad="76200" dist="38100" dir="7800000" algn="tl" rotWithShape="0">
-              <a:srgbClr val="000000">
-                <a:alpha val="40000"/>
-              </a:srgbClr>
-            </a:outerShdw>
-          </a:effectLst>
-          <a:scene3d>
-            <a:camera prst="orthographicFront"/>
-            <a:lightRig rig="contrasting" dir="t">
-              <a:rot lat="0" lon="0" rev="4200000"/>
-            </a:lightRig>
-          </a:scene3d>
-          <a:sp3d prstMaterial="plastic">
-            <a:bevelT w="381000" h="114300" prst="relaxedInset"/>
-            <a:contourClr>
-              <a:srgbClr val="969696"/>
-            </a:contourClr>
-          </a:sp3d>
-          <a:extLst>
-            <a:ext uri="{909E8E84-426E-40DD-AFC4-6F175D3DCCD1}">
-              <a14:hiddenFill xmlns:a14="http://schemas.microsoft.com/office/drawing/2010/main">
-                <a:solidFill>
-                  <a:srgbClr val="FFFFFF"/>
-                </a:solidFill>
-              </a14:hiddenFill>
-            </a:ext>
-          </a:extLst>
-        </p:spPr>
-      </p:pic>
       <p:sp>
         <p:nvSpPr>
           <p:cNvPr id="10" name="TextBox 9">
@@ -8180,7 +7977,7 @@
           <p:nvPr/>
         </p:nvPicPr>
         <p:blipFill>
-          <a:blip r:embed="rId4">
+          <a:blip r:embed="rId3">
             <a:extLst>
               <a:ext uri="{28A0092B-C50C-407E-A947-70E740481C1C}">
                 <a14:useLocalDpi xmlns:a14="http://schemas.microsoft.com/office/drawing/2010/main" val="0"/>
@@ -8199,6 +7996,55 @@
           <a:prstGeom prst="rect">
             <a:avLst/>
           </a:prstGeom>
+        </p:spPr>
+      </p:pic>
+      <p:pic>
+        <p:nvPicPr>
+          <p:cNvPr id="8" name="Picture 7">
+            <a:extLst>
+              <a:ext uri="{FF2B5EF4-FFF2-40B4-BE49-F238E27FC236}">
+                <a16:creationId xmlns:a16="http://schemas.microsoft.com/office/drawing/2014/main" id="{9C6CF02B-E89E-15E7-C2EA-477D0E0F4640}"/>
+              </a:ext>
+            </a:extLst>
+          </p:cNvPr>
+          <p:cNvPicPr>
+            <a:picLocks noChangeAspect="1"/>
+          </p:cNvPicPr>
+          <p:nvPr/>
+        </p:nvPicPr>
+        <p:blipFill>
+          <a:blip r:embed="rId4">
+            <a:extLst>
+              <a:ext uri="{28A0092B-C50C-407E-A947-70E740481C1C}">
+                <a14:useLocalDpi xmlns:a14="http://schemas.microsoft.com/office/drawing/2010/main" val="0"/>
+              </a:ext>
+            </a:extLst>
+          </a:blip>
+          <a:stretch>
+            <a:fillRect/>
+          </a:stretch>
+        </p:blipFill>
+        <p:spPr>
+          <a:xfrm>
+            <a:off x="118537" y="237068"/>
+            <a:ext cx="1388534" cy="1391436"/>
+          </a:xfrm>
+          <a:prstGeom prst="roundRect">
+            <a:avLst>
+              <a:gd name="adj" fmla="val 8594"/>
+            </a:avLst>
+          </a:prstGeom>
+          <a:solidFill>
+            <a:srgbClr val="FFFFFF">
+              <a:shade val="85000"/>
+            </a:srgbClr>
+          </a:solidFill>
+          <a:ln>
+            <a:noFill/>
+          </a:ln>
+          <a:effectLst>
+            <a:reflection blurRad="12700" stA="38000" endPos="28000" dist="5000" dir="5400000" sy="-100000" algn="bl" rotWithShape="0"/>
+          </a:effectLst>
         </p:spPr>
       </p:pic>
     </p:spTree>
@@ -8391,77 +8237,6 @@
           </a:p>
         </p:txBody>
       </p:sp>
-      <p:pic>
-        <p:nvPicPr>
-          <p:cNvPr id="6" name="Picture 4" descr="Sathya Sai Babas birthday ...">
-            <a:extLst>
-              <a:ext uri="{FF2B5EF4-FFF2-40B4-BE49-F238E27FC236}">
-                <a16:creationId xmlns:a16="http://schemas.microsoft.com/office/drawing/2014/main" id="{702C6C89-595E-BA36-6D88-B31E30B87AE2}"/>
-              </a:ext>
-            </a:extLst>
-          </p:cNvPr>
-          <p:cNvPicPr>
-            <a:picLocks noChangeAspect="1" noChangeArrowheads="1"/>
-          </p:cNvPicPr>
-          <p:nvPr/>
-        </p:nvPicPr>
-        <p:blipFill>
-          <a:blip r:embed="rId3">
-            <a:alphaModFix/>
-            <a:extLst>
-              <a:ext uri="{28A0092B-C50C-407E-A947-70E740481C1C}">
-                <a14:useLocalDpi xmlns:a14="http://schemas.microsoft.com/office/drawing/2010/main" val="0"/>
-              </a:ext>
-            </a:extLst>
-          </a:blip>
-          <a:srcRect/>
-          <a:stretch>
-            <a:fillRect/>
-          </a:stretch>
-        </p:blipFill>
-        <p:spPr bwMode="auto">
-          <a:xfrm>
-            <a:off x="200298" y="156754"/>
-            <a:ext cx="1202837" cy="1471749"/>
-          </a:xfrm>
-          <a:prstGeom prst="roundRect">
-            <a:avLst>
-              <a:gd name="adj" fmla="val 16667"/>
-            </a:avLst>
-          </a:prstGeom>
-          <a:ln>
-            <a:noFill/>
-          </a:ln>
-          <a:effectLst>
-            <a:outerShdw blurRad="76200" dist="38100" dir="7800000" algn="tl" rotWithShape="0">
-              <a:srgbClr val="000000">
-                <a:alpha val="40000"/>
-              </a:srgbClr>
-            </a:outerShdw>
-          </a:effectLst>
-          <a:scene3d>
-            <a:camera prst="orthographicFront"/>
-            <a:lightRig rig="contrasting" dir="t">
-              <a:rot lat="0" lon="0" rev="4200000"/>
-            </a:lightRig>
-          </a:scene3d>
-          <a:sp3d prstMaterial="plastic">
-            <a:bevelT w="381000" h="114300" prst="relaxedInset"/>
-            <a:contourClr>
-              <a:srgbClr val="969696"/>
-            </a:contourClr>
-          </a:sp3d>
-          <a:extLst>
-            <a:ext uri="{909E8E84-426E-40DD-AFC4-6F175D3DCCD1}">
-              <a14:hiddenFill xmlns:a14="http://schemas.microsoft.com/office/drawing/2010/main">
-                <a:solidFill>
-                  <a:srgbClr val="FFFFFF"/>
-                </a:solidFill>
-              </a14:hiddenFill>
-            </a:ext>
-          </a:extLst>
-        </p:spPr>
-      </p:pic>
       <p:sp>
         <p:nvSpPr>
           <p:cNvPr id="10" name="TextBox 9">
@@ -8938,7 +8713,7 @@
           <p:nvPr/>
         </p:nvPicPr>
         <p:blipFill>
-          <a:blip r:embed="rId4">
+          <a:blip r:embed="rId3">
             <a:extLst>
               <a:ext uri="{28A0092B-C50C-407E-A947-70E740481C1C}">
                 <a14:useLocalDpi xmlns:a14="http://schemas.microsoft.com/office/drawing/2010/main" val="0"/>
@@ -8957,6 +8732,55 @@
           <a:prstGeom prst="rect">
             <a:avLst/>
           </a:prstGeom>
+        </p:spPr>
+      </p:pic>
+      <p:pic>
+        <p:nvPicPr>
+          <p:cNvPr id="8" name="Picture 7">
+            <a:extLst>
+              <a:ext uri="{FF2B5EF4-FFF2-40B4-BE49-F238E27FC236}">
+                <a16:creationId xmlns:a16="http://schemas.microsoft.com/office/drawing/2014/main" id="{893F1383-1FFA-4F3D-297A-3BCA0BC4C224}"/>
+              </a:ext>
+            </a:extLst>
+          </p:cNvPr>
+          <p:cNvPicPr>
+            <a:picLocks noChangeAspect="1"/>
+          </p:cNvPicPr>
+          <p:nvPr/>
+        </p:nvPicPr>
+        <p:blipFill>
+          <a:blip r:embed="rId4">
+            <a:extLst>
+              <a:ext uri="{28A0092B-C50C-407E-A947-70E740481C1C}">
+                <a14:useLocalDpi xmlns:a14="http://schemas.microsoft.com/office/drawing/2010/main" val="0"/>
+              </a:ext>
+            </a:extLst>
+          </a:blip>
+          <a:stretch>
+            <a:fillRect/>
+          </a:stretch>
+        </p:blipFill>
+        <p:spPr>
+          <a:xfrm>
+            <a:off x="118537" y="237068"/>
+            <a:ext cx="1388534" cy="1391436"/>
+          </a:xfrm>
+          <a:prstGeom prst="roundRect">
+            <a:avLst>
+              <a:gd name="adj" fmla="val 8594"/>
+            </a:avLst>
+          </a:prstGeom>
+          <a:solidFill>
+            <a:srgbClr val="FFFFFF">
+              <a:shade val="85000"/>
+            </a:srgbClr>
+          </a:solidFill>
+          <a:ln>
+            <a:noFill/>
+          </a:ln>
+          <a:effectLst>
+            <a:reflection blurRad="12700" stA="38000" endPos="28000" dist="5000" dir="5400000" sy="-100000" algn="bl" rotWithShape="0"/>
+          </a:effectLst>
         </p:spPr>
       </p:pic>
     </p:spTree>
@@ -9149,77 +8973,6 @@
           </a:p>
         </p:txBody>
       </p:sp>
-      <p:pic>
-        <p:nvPicPr>
-          <p:cNvPr id="6" name="Picture 4" descr="Sathya Sai Babas birthday ...">
-            <a:extLst>
-              <a:ext uri="{FF2B5EF4-FFF2-40B4-BE49-F238E27FC236}">
-                <a16:creationId xmlns:a16="http://schemas.microsoft.com/office/drawing/2014/main" id="{FE1486ED-3C61-0F11-E608-5A2D807756B1}"/>
-              </a:ext>
-            </a:extLst>
-          </p:cNvPr>
-          <p:cNvPicPr>
-            <a:picLocks noChangeAspect="1" noChangeArrowheads="1"/>
-          </p:cNvPicPr>
-          <p:nvPr/>
-        </p:nvPicPr>
-        <p:blipFill>
-          <a:blip r:embed="rId3">
-            <a:alphaModFix/>
-            <a:extLst>
-              <a:ext uri="{28A0092B-C50C-407E-A947-70E740481C1C}">
-                <a14:useLocalDpi xmlns:a14="http://schemas.microsoft.com/office/drawing/2010/main" val="0"/>
-              </a:ext>
-            </a:extLst>
-          </a:blip>
-          <a:srcRect/>
-          <a:stretch>
-            <a:fillRect/>
-          </a:stretch>
-        </p:blipFill>
-        <p:spPr bwMode="auto">
-          <a:xfrm>
-            <a:off x="200298" y="156754"/>
-            <a:ext cx="1202837" cy="1471749"/>
-          </a:xfrm>
-          <a:prstGeom prst="roundRect">
-            <a:avLst>
-              <a:gd name="adj" fmla="val 16667"/>
-            </a:avLst>
-          </a:prstGeom>
-          <a:ln>
-            <a:noFill/>
-          </a:ln>
-          <a:effectLst>
-            <a:outerShdw blurRad="76200" dist="38100" dir="7800000" algn="tl" rotWithShape="0">
-              <a:srgbClr val="000000">
-                <a:alpha val="40000"/>
-              </a:srgbClr>
-            </a:outerShdw>
-          </a:effectLst>
-          <a:scene3d>
-            <a:camera prst="orthographicFront"/>
-            <a:lightRig rig="contrasting" dir="t">
-              <a:rot lat="0" lon="0" rev="4200000"/>
-            </a:lightRig>
-          </a:scene3d>
-          <a:sp3d prstMaterial="plastic">
-            <a:bevelT w="381000" h="114300" prst="relaxedInset"/>
-            <a:contourClr>
-              <a:srgbClr val="969696"/>
-            </a:contourClr>
-          </a:sp3d>
-          <a:extLst>
-            <a:ext uri="{909E8E84-426E-40DD-AFC4-6F175D3DCCD1}">
-              <a14:hiddenFill xmlns:a14="http://schemas.microsoft.com/office/drawing/2010/main">
-                <a:solidFill>
-                  <a:srgbClr val="FFFFFF"/>
-                </a:solidFill>
-              </a14:hiddenFill>
-            </a:ext>
-          </a:extLst>
-        </p:spPr>
-      </p:pic>
       <p:sp>
         <p:nvSpPr>
           <p:cNvPr id="10" name="TextBox 9">
@@ -9696,7 +9449,7 @@
           <p:nvPr/>
         </p:nvPicPr>
         <p:blipFill>
-          <a:blip r:embed="rId4">
+          <a:blip r:embed="rId3">
             <a:extLst>
               <a:ext uri="{28A0092B-C50C-407E-A947-70E740481C1C}">
                 <a14:useLocalDpi xmlns:a14="http://schemas.microsoft.com/office/drawing/2010/main" val="0"/>
@@ -9715,6 +9468,55 @@
           <a:prstGeom prst="rect">
             <a:avLst/>
           </a:prstGeom>
+        </p:spPr>
+      </p:pic>
+      <p:pic>
+        <p:nvPicPr>
+          <p:cNvPr id="8" name="Picture 7">
+            <a:extLst>
+              <a:ext uri="{FF2B5EF4-FFF2-40B4-BE49-F238E27FC236}">
+                <a16:creationId xmlns:a16="http://schemas.microsoft.com/office/drawing/2014/main" id="{B1F55820-3E9A-2F69-2FEF-884D5B5E8BFF}"/>
+              </a:ext>
+            </a:extLst>
+          </p:cNvPr>
+          <p:cNvPicPr>
+            <a:picLocks noChangeAspect="1"/>
+          </p:cNvPicPr>
+          <p:nvPr/>
+        </p:nvPicPr>
+        <p:blipFill>
+          <a:blip r:embed="rId4">
+            <a:extLst>
+              <a:ext uri="{28A0092B-C50C-407E-A947-70E740481C1C}">
+                <a14:useLocalDpi xmlns:a14="http://schemas.microsoft.com/office/drawing/2010/main" val="0"/>
+              </a:ext>
+            </a:extLst>
+          </a:blip>
+          <a:stretch>
+            <a:fillRect/>
+          </a:stretch>
+        </p:blipFill>
+        <p:spPr>
+          <a:xfrm>
+            <a:off x="118537" y="237068"/>
+            <a:ext cx="1388534" cy="1391436"/>
+          </a:xfrm>
+          <a:prstGeom prst="roundRect">
+            <a:avLst>
+              <a:gd name="adj" fmla="val 8594"/>
+            </a:avLst>
+          </a:prstGeom>
+          <a:solidFill>
+            <a:srgbClr val="FFFFFF">
+              <a:shade val="85000"/>
+            </a:srgbClr>
+          </a:solidFill>
+          <a:ln>
+            <a:noFill/>
+          </a:ln>
+          <a:effectLst>
+            <a:reflection blurRad="12700" stA="38000" endPos="28000" dist="5000" dir="5400000" sy="-100000" algn="bl" rotWithShape="0"/>
+          </a:effectLst>
         </p:spPr>
       </p:pic>
     </p:spTree>
@@ -9907,77 +9709,6 @@
           </a:p>
         </p:txBody>
       </p:sp>
-      <p:pic>
-        <p:nvPicPr>
-          <p:cNvPr id="6" name="Picture 4" descr="Sathya Sai Babas birthday ...">
-            <a:extLst>
-              <a:ext uri="{FF2B5EF4-FFF2-40B4-BE49-F238E27FC236}">
-                <a16:creationId xmlns:a16="http://schemas.microsoft.com/office/drawing/2014/main" id="{31450C38-2E5D-0499-9371-C27013E20128}"/>
-              </a:ext>
-            </a:extLst>
-          </p:cNvPr>
-          <p:cNvPicPr>
-            <a:picLocks noChangeAspect="1" noChangeArrowheads="1"/>
-          </p:cNvPicPr>
-          <p:nvPr/>
-        </p:nvPicPr>
-        <p:blipFill>
-          <a:blip r:embed="rId3">
-            <a:alphaModFix/>
-            <a:extLst>
-              <a:ext uri="{28A0092B-C50C-407E-A947-70E740481C1C}">
-                <a14:useLocalDpi xmlns:a14="http://schemas.microsoft.com/office/drawing/2010/main" val="0"/>
-              </a:ext>
-            </a:extLst>
-          </a:blip>
-          <a:srcRect/>
-          <a:stretch>
-            <a:fillRect/>
-          </a:stretch>
-        </p:blipFill>
-        <p:spPr bwMode="auto">
-          <a:xfrm>
-            <a:off x="200298" y="156754"/>
-            <a:ext cx="1202837" cy="1471749"/>
-          </a:xfrm>
-          <a:prstGeom prst="roundRect">
-            <a:avLst>
-              <a:gd name="adj" fmla="val 16667"/>
-            </a:avLst>
-          </a:prstGeom>
-          <a:ln>
-            <a:noFill/>
-          </a:ln>
-          <a:effectLst>
-            <a:outerShdw blurRad="76200" dist="38100" dir="7800000" algn="tl" rotWithShape="0">
-              <a:srgbClr val="000000">
-                <a:alpha val="40000"/>
-              </a:srgbClr>
-            </a:outerShdw>
-          </a:effectLst>
-          <a:scene3d>
-            <a:camera prst="orthographicFront"/>
-            <a:lightRig rig="contrasting" dir="t">
-              <a:rot lat="0" lon="0" rev="4200000"/>
-            </a:lightRig>
-          </a:scene3d>
-          <a:sp3d prstMaterial="plastic">
-            <a:bevelT w="381000" h="114300" prst="relaxedInset"/>
-            <a:contourClr>
-              <a:srgbClr val="969696"/>
-            </a:contourClr>
-          </a:sp3d>
-          <a:extLst>
-            <a:ext uri="{909E8E84-426E-40DD-AFC4-6F175D3DCCD1}">
-              <a14:hiddenFill xmlns:a14="http://schemas.microsoft.com/office/drawing/2010/main">
-                <a:solidFill>
-                  <a:srgbClr val="FFFFFF"/>
-                </a:solidFill>
-              </a14:hiddenFill>
-            </a:ext>
-          </a:extLst>
-        </p:spPr>
-      </p:pic>
       <p:sp>
         <p:nvSpPr>
           <p:cNvPr id="10" name="TextBox 9">
@@ -10454,7 +10185,7 @@
           <p:nvPr/>
         </p:nvPicPr>
         <p:blipFill>
-          <a:blip r:embed="rId4">
+          <a:blip r:embed="rId3">
             <a:extLst>
               <a:ext uri="{28A0092B-C50C-407E-A947-70E740481C1C}">
                 <a14:useLocalDpi xmlns:a14="http://schemas.microsoft.com/office/drawing/2010/main" val="0"/>
@@ -10473,6 +10204,55 @@
           <a:prstGeom prst="rect">
             <a:avLst/>
           </a:prstGeom>
+        </p:spPr>
+      </p:pic>
+      <p:pic>
+        <p:nvPicPr>
+          <p:cNvPr id="8" name="Picture 7">
+            <a:extLst>
+              <a:ext uri="{FF2B5EF4-FFF2-40B4-BE49-F238E27FC236}">
+                <a16:creationId xmlns:a16="http://schemas.microsoft.com/office/drawing/2014/main" id="{B69528C2-B587-A5C6-00F2-5D8DA72BDA01}"/>
+              </a:ext>
+            </a:extLst>
+          </p:cNvPr>
+          <p:cNvPicPr>
+            <a:picLocks noChangeAspect="1"/>
+          </p:cNvPicPr>
+          <p:nvPr/>
+        </p:nvPicPr>
+        <p:blipFill>
+          <a:blip r:embed="rId4">
+            <a:extLst>
+              <a:ext uri="{28A0092B-C50C-407E-A947-70E740481C1C}">
+                <a14:useLocalDpi xmlns:a14="http://schemas.microsoft.com/office/drawing/2010/main" val="0"/>
+              </a:ext>
+            </a:extLst>
+          </a:blip>
+          <a:stretch>
+            <a:fillRect/>
+          </a:stretch>
+        </p:blipFill>
+        <p:spPr>
+          <a:xfrm>
+            <a:off x="118537" y="237068"/>
+            <a:ext cx="1388534" cy="1391436"/>
+          </a:xfrm>
+          <a:prstGeom prst="roundRect">
+            <a:avLst>
+              <a:gd name="adj" fmla="val 8594"/>
+            </a:avLst>
+          </a:prstGeom>
+          <a:solidFill>
+            <a:srgbClr val="FFFFFF">
+              <a:shade val="85000"/>
+            </a:srgbClr>
+          </a:solidFill>
+          <a:ln>
+            <a:noFill/>
+          </a:ln>
+          <a:effectLst>
+            <a:reflection blurRad="12700" stA="38000" endPos="28000" dist="5000" dir="5400000" sy="-100000" algn="bl" rotWithShape="0"/>
+          </a:effectLst>
         </p:spPr>
       </p:pic>
     </p:spTree>
@@ -10665,77 +10445,6 @@
           </a:p>
         </p:txBody>
       </p:sp>
-      <p:pic>
-        <p:nvPicPr>
-          <p:cNvPr id="6" name="Picture 4" descr="Sathya Sai Babas birthday ...">
-            <a:extLst>
-              <a:ext uri="{FF2B5EF4-FFF2-40B4-BE49-F238E27FC236}">
-                <a16:creationId xmlns:a16="http://schemas.microsoft.com/office/drawing/2014/main" id="{950C670D-A0F2-16CB-B10B-9FEFDFFB419D}"/>
-              </a:ext>
-            </a:extLst>
-          </p:cNvPr>
-          <p:cNvPicPr>
-            <a:picLocks noChangeAspect="1" noChangeArrowheads="1"/>
-          </p:cNvPicPr>
-          <p:nvPr/>
-        </p:nvPicPr>
-        <p:blipFill>
-          <a:blip r:embed="rId3">
-            <a:alphaModFix/>
-            <a:extLst>
-              <a:ext uri="{28A0092B-C50C-407E-A947-70E740481C1C}">
-                <a14:useLocalDpi xmlns:a14="http://schemas.microsoft.com/office/drawing/2010/main" val="0"/>
-              </a:ext>
-            </a:extLst>
-          </a:blip>
-          <a:srcRect/>
-          <a:stretch>
-            <a:fillRect/>
-          </a:stretch>
-        </p:blipFill>
-        <p:spPr bwMode="auto">
-          <a:xfrm>
-            <a:off x="200298" y="156754"/>
-            <a:ext cx="1202837" cy="1471749"/>
-          </a:xfrm>
-          <a:prstGeom prst="roundRect">
-            <a:avLst>
-              <a:gd name="adj" fmla="val 16667"/>
-            </a:avLst>
-          </a:prstGeom>
-          <a:ln>
-            <a:noFill/>
-          </a:ln>
-          <a:effectLst>
-            <a:outerShdw blurRad="76200" dist="38100" dir="7800000" algn="tl" rotWithShape="0">
-              <a:srgbClr val="000000">
-                <a:alpha val="40000"/>
-              </a:srgbClr>
-            </a:outerShdw>
-          </a:effectLst>
-          <a:scene3d>
-            <a:camera prst="orthographicFront"/>
-            <a:lightRig rig="contrasting" dir="t">
-              <a:rot lat="0" lon="0" rev="4200000"/>
-            </a:lightRig>
-          </a:scene3d>
-          <a:sp3d prstMaterial="plastic">
-            <a:bevelT w="381000" h="114300" prst="relaxedInset"/>
-            <a:contourClr>
-              <a:srgbClr val="969696"/>
-            </a:contourClr>
-          </a:sp3d>
-          <a:extLst>
-            <a:ext uri="{909E8E84-426E-40DD-AFC4-6F175D3DCCD1}">
-              <a14:hiddenFill xmlns:a14="http://schemas.microsoft.com/office/drawing/2010/main">
-                <a:solidFill>
-                  <a:srgbClr val="FFFFFF"/>
-                </a:solidFill>
-              </a14:hiddenFill>
-            </a:ext>
-          </a:extLst>
-        </p:spPr>
-      </p:pic>
       <p:sp>
         <p:nvSpPr>
           <p:cNvPr id="10" name="TextBox 9">
@@ -11212,7 +10921,7 @@
           <p:nvPr/>
         </p:nvPicPr>
         <p:blipFill>
-          <a:blip r:embed="rId4">
+          <a:blip r:embed="rId3">
             <a:extLst>
               <a:ext uri="{28A0092B-C50C-407E-A947-70E740481C1C}">
                 <a14:useLocalDpi xmlns:a14="http://schemas.microsoft.com/office/drawing/2010/main" val="0"/>
@@ -11231,6 +10940,55 @@
           <a:prstGeom prst="rect">
             <a:avLst/>
           </a:prstGeom>
+        </p:spPr>
+      </p:pic>
+      <p:pic>
+        <p:nvPicPr>
+          <p:cNvPr id="9" name="Picture 8">
+            <a:extLst>
+              <a:ext uri="{FF2B5EF4-FFF2-40B4-BE49-F238E27FC236}">
+                <a16:creationId xmlns:a16="http://schemas.microsoft.com/office/drawing/2014/main" id="{E3BE6563-B379-A7C9-CD50-BA11D23E8D9C}"/>
+              </a:ext>
+            </a:extLst>
+          </p:cNvPr>
+          <p:cNvPicPr>
+            <a:picLocks noChangeAspect="1"/>
+          </p:cNvPicPr>
+          <p:nvPr/>
+        </p:nvPicPr>
+        <p:blipFill>
+          <a:blip r:embed="rId4">
+            <a:extLst>
+              <a:ext uri="{28A0092B-C50C-407E-A947-70E740481C1C}">
+                <a14:useLocalDpi xmlns:a14="http://schemas.microsoft.com/office/drawing/2010/main" val="0"/>
+              </a:ext>
+            </a:extLst>
+          </a:blip>
+          <a:stretch>
+            <a:fillRect/>
+          </a:stretch>
+        </p:blipFill>
+        <p:spPr>
+          <a:xfrm>
+            <a:off x="118537" y="237068"/>
+            <a:ext cx="1388534" cy="1391436"/>
+          </a:xfrm>
+          <a:prstGeom prst="roundRect">
+            <a:avLst>
+              <a:gd name="adj" fmla="val 8594"/>
+            </a:avLst>
+          </a:prstGeom>
+          <a:solidFill>
+            <a:srgbClr val="FFFFFF">
+              <a:shade val="85000"/>
+            </a:srgbClr>
+          </a:solidFill>
+          <a:ln>
+            <a:noFill/>
+          </a:ln>
+          <a:effectLst>
+            <a:reflection blurRad="12700" stA="38000" endPos="28000" dist="5000" dir="5400000" sy="-100000" algn="bl" rotWithShape="0"/>
+          </a:effectLst>
         </p:spPr>
       </p:pic>
     </p:spTree>
@@ -11423,77 +11181,6 @@
           </a:p>
         </p:txBody>
       </p:sp>
-      <p:pic>
-        <p:nvPicPr>
-          <p:cNvPr id="6" name="Picture 4" descr="Sathya Sai Babas birthday ...">
-            <a:extLst>
-              <a:ext uri="{FF2B5EF4-FFF2-40B4-BE49-F238E27FC236}">
-                <a16:creationId xmlns:a16="http://schemas.microsoft.com/office/drawing/2014/main" id="{C78F2582-FC6D-7E25-C2BA-20552B423E22}"/>
-              </a:ext>
-            </a:extLst>
-          </p:cNvPr>
-          <p:cNvPicPr>
-            <a:picLocks noChangeAspect="1" noChangeArrowheads="1"/>
-          </p:cNvPicPr>
-          <p:nvPr/>
-        </p:nvPicPr>
-        <p:blipFill>
-          <a:blip r:embed="rId3">
-            <a:alphaModFix/>
-            <a:extLst>
-              <a:ext uri="{28A0092B-C50C-407E-A947-70E740481C1C}">
-                <a14:useLocalDpi xmlns:a14="http://schemas.microsoft.com/office/drawing/2010/main" val="0"/>
-              </a:ext>
-            </a:extLst>
-          </a:blip>
-          <a:srcRect/>
-          <a:stretch>
-            <a:fillRect/>
-          </a:stretch>
-        </p:blipFill>
-        <p:spPr bwMode="auto">
-          <a:xfrm>
-            <a:off x="200298" y="156754"/>
-            <a:ext cx="1202837" cy="1471749"/>
-          </a:xfrm>
-          <a:prstGeom prst="roundRect">
-            <a:avLst>
-              <a:gd name="adj" fmla="val 16667"/>
-            </a:avLst>
-          </a:prstGeom>
-          <a:ln>
-            <a:noFill/>
-          </a:ln>
-          <a:effectLst>
-            <a:outerShdw blurRad="76200" dist="38100" dir="7800000" algn="tl" rotWithShape="0">
-              <a:srgbClr val="000000">
-                <a:alpha val="40000"/>
-              </a:srgbClr>
-            </a:outerShdw>
-          </a:effectLst>
-          <a:scene3d>
-            <a:camera prst="orthographicFront"/>
-            <a:lightRig rig="contrasting" dir="t">
-              <a:rot lat="0" lon="0" rev="4200000"/>
-            </a:lightRig>
-          </a:scene3d>
-          <a:sp3d prstMaterial="plastic">
-            <a:bevelT w="381000" h="114300" prst="relaxedInset"/>
-            <a:contourClr>
-              <a:srgbClr val="969696"/>
-            </a:contourClr>
-          </a:sp3d>
-          <a:extLst>
-            <a:ext uri="{909E8E84-426E-40DD-AFC4-6F175D3DCCD1}">
-              <a14:hiddenFill xmlns:a14="http://schemas.microsoft.com/office/drawing/2010/main">
-                <a:solidFill>
-                  <a:srgbClr val="FFFFFF"/>
-                </a:solidFill>
-              </a14:hiddenFill>
-            </a:ext>
-          </a:extLst>
-        </p:spPr>
-      </p:pic>
       <p:sp>
         <p:nvSpPr>
           <p:cNvPr id="10" name="TextBox 9">
@@ -11970,7 +11657,7 @@
           <p:nvPr/>
         </p:nvPicPr>
         <p:blipFill>
-          <a:blip r:embed="rId4">
+          <a:blip r:embed="rId3">
             <a:extLst>
               <a:ext uri="{28A0092B-C50C-407E-A947-70E740481C1C}">
                 <a14:useLocalDpi xmlns:a14="http://schemas.microsoft.com/office/drawing/2010/main" val="0"/>
@@ -11989,6 +11676,55 @@
           <a:prstGeom prst="rect">
             <a:avLst/>
           </a:prstGeom>
+        </p:spPr>
+      </p:pic>
+      <p:pic>
+        <p:nvPicPr>
+          <p:cNvPr id="8" name="Picture 7">
+            <a:extLst>
+              <a:ext uri="{FF2B5EF4-FFF2-40B4-BE49-F238E27FC236}">
+                <a16:creationId xmlns:a16="http://schemas.microsoft.com/office/drawing/2014/main" id="{20B7064A-E9D9-75F7-B8BD-9C48065C9FB7}"/>
+              </a:ext>
+            </a:extLst>
+          </p:cNvPr>
+          <p:cNvPicPr>
+            <a:picLocks noChangeAspect="1"/>
+          </p:cNvPicPr>
+          <p:nvPr/>
+        </p:nvPicPr>
+        <p:blipFill>
+          <a:blip r:embed="rId4">
+            <a:extLst>
+              <a:ext uri="{28A0092B-C50C-407E-A947-70E740481C1C}">
+                <a14:useLocalDpi xmlns:a14="http://schemas.microsoft.com/office/drawing/2010/main" val="0"/>
+              </a:ext>
+            </a:extLst>
+          </a:blip>
+          <a:stretch>
+            <a:fillRect/>
+          </a:stretch>
+        </p:blipFill>
+        <p:spPr>
+          <a:xfrm>
+            <a:off x="118537" y="237068"/>
+            <a:ext cx="1388534" cy="1391436"/>
+          </a:xfrm>
+          <a:prstGeom prst="roundRect">
+            <a:avLst>
+              <a:gd name="adj" fmla="val 8594"/>
+            </a:avLst>
+          </a:prstGeom>
+          <a:solidFill>
+            <a:srgbClr val="FFFFFF">
+              <a:shade val="85000"/>
+            </a:srgbClr>
+          </a:solidFill>
+          <a:ln>
+            <a:noFill/>
+          </a:ln>
+          <a:effectLst>
+            <a:reflection blurRad="12700" stA="38000" endPos="28000" dist="5000" dir="5400000" sy="-100000" algn="bl" rotWithShape="0"/>
+          </a:effectLst>
         </p:spPr>
       </p:pic>
     </p:spTree>

</xml_diff>